<commit_message>
Changes for Length Of Stay
</commit_message>
<xml_diff>
--- a/UNOS/UNOS_Discretization.pptx
+++ b/UNOS/UNOS_Discretization.pptx
@@ -9,7 +9,8 @@
     <p:sldId id="260" r:id="rId3"/>
     <p:sldId id="257" r:id="rId4"/>
     <p:sldId id="262" r:id="rId5"/>
-    <p:sldId id="261" r:id="rId6"/>
+    <p:sldId id="263" r:id="rId6"/>
+    <p:sldId id="261" r:id="rId7"/>
   </p:sldIdLst>
   <p:sldSz cx="12192000" cy="6858000"/>
   <p:notesSz cx="6858000" cy="9144000"/>
@@ -3606,7 +3607,7 @@
           <a:p>
             <a:r>
               <a:rPr lang="en-US" dirty="0"/>
-              <a:t>Data Cleaning</a:t>
+              <a:t>Data Engineering</a:t>
             </a:r>
           </a:p>
         </p:txBody>
@@ -3635,7 +3636,7 @@
         </p:spPr>
         <p:txBody>
           <a:bodyPr>
-            <a:normAutofit fontScale="77500" lnSpcReduction="20000"/>
+            <a:normAutofit fontScale="92500" lnSpcReduction="10000"/>
           </a:bodyPr>
           <a:lstStyle/>
           <a:p>
@@ -3742,77 +3743,65 @@
           </a:p>
           <a:p>
             <a:pPr lvl="3"/>
-            <a:endParaRPr lang="en-US" dirty="0">
-              <a:latin typeface="system-ui"/>
-            </a:endParaRPr>
-          </a:p>
-          <a:p>
-            <a:pPr lvl="3"/>
-            <a:endParaRPr lang="en-US" dirty="0">
-              <a:latin typeface="system-ui"/>
-            </a:endParaRPr>
-          </a:p>
-          <a:p>
-            <a:pPr lvl="3"/>
-            <a:endParaRPr lang="en-US" dirty="0">
-              <a:latin typeface="system-ui"/>
-            </a:endParaRPr>
-          </a:p>
-          <a:p>
-            <a:pPr lvl="3"/>
             <a:r>
               <a:rPr lang="en-US" dirty="0">
                 <a:latin typeface="system-ui"/>
               </a:rPr>
-              <a:t>Candidate with any life support into a new single binary feature.</a:t>
+              <a:t>Combine &amp; Interaction SYS/PA_DIA/PA_MIN/PWC</a:t>
+            </a:r>
+          </a:p>
+          <a:p>
+            <a:pPr lvl="4"/>
+            <a:r>
+              <a:rPr lang="en-US" dirty="0">
+                <a:latin typeface="system-ui"/>
+              </a:rPr>
+              <a:t>Correlation above positive .8</a:t>
             </a:r>
           </a:p>
           <a:p>
             <a:pPr lvl="2"/>
             <a:r>
-              <a:rPr lang="en-US" b="0" i="0" dirty="0">
-                <a:solidFill>
-                  <a:srgbClr val="001D35"/>
-                </a:solidFill>
-                <a:effectLst/>
-                <a:latin typeface="Google Sans"/>
+              <a:rPr lang="en-US" dirty="0">
+                <a:latin typeface="system-ui"/>
               </a:rPr>
-              <a:t>Hemodynamics &amp; Inotropic and Vasodilator &amp; etc.</a:t>
+              <a:t>Any Life Support into a new single ordinal feature.</a:t>
             </a:r>
           </a:p>
           <a:p>
             <a:pPr lvl="3"/>
             <a:r>
-              <a:rPr lang="en-US" b="0" i="0" dirty="0">
-                <a:solidFill>
-                  <a:srgbClr val="001D35"/>
-                </a:solidFill>
-                <a:effectLst/>
-                <a:latin typeface="Google Sans"/>
+              <a:rPr lang="en-US" dirty="0">
+                <a:latin typeface="system-ui"/>
               </a:rPr>
-              <a:t>Chi2/Cramer's V score statistics test for categorical features to determine the association between categories before consolidating features</a:t>
+              <a:t>Total Count for all ‘Yes’</a:t>
+            </a:r>
+          </a:p>
+          <a:p>
+            <a:pPr lvl="2"/>
+            <a:r>
+              <a:rPr lang="en-US" dirty="0">
+                <a:latin typeface="system-ui"/>
+              </a:rPr>
+              <a:t>Age/Weight/Height</a:t>
             </a:r>
           </a:p>
           <a:p>
             <a:pPr lvl="3"/>
             <a:r>
-              <a:rPr lang="en-US" dirty="0"/>
-              <a:t>Consolidate features that contain prior Heart transplantation &amp; remove any measurements taken after the surgery</a:t>
+              <a:rPr lang="en-US" dirty="0">
+                <a:latin typeface="system-ui"/>
+              </a:rPr>
+              <a:t>New feature: difference</a:t>
             </a:r>
           </a:p>
           <a:p>
             <a:pPr lvl="2"/>
-            <a:r>
-              <a:rPr lang="en-US" dirty="0"/>
-              <a:t>Numeric Categories (Nominal/Ordinal)</a:t>
-            </a:r>
-          </a:p>
-          <a:p>
-            <a:pPr lvl="3"/>
-            <a:r>
-              <a:rPr lang="en-US" dirty="0"/>
-              <a:t>Transform features into description using Data Dictionary excel from optn-star-files-data-dictionary.xlsx</a:t>
-            </a:r>
+            <a:endParaRPr lang="en-US" dirty="0"/>
+          </a:p>
+          <a:p>
+            <a:pPr lvl="2"/>
+            <a:endParaRPr lang="en-US" dirty="0"/>
           </a:p>
           <a:p>
             <a:pPr lvl="3"/>
@@ -3920,63 +3909,135 @@
           </a:p>
         </p:txBody>
       </p:sp>
-      <p:sp>
-        <p:nvSpPr>
-          <p:cNvPr id="3" name="Content Placeholder 2">
-            <a:extLst>
-              <a:ext uri="{FF2B5EF4-FFF2-40B4-BE49-F238E27FC236}">
-                <a16:creationId xmlns:a16="http://schemas.microsoft.com/office/drawing/2014/main" id="{D023D7EA-A15E-A260-40C2-5E4340777B51}"/>
-              </a:ext>
-            </a:extLst>
-          </p:cNvPr>
-          <p:cNvSpPr>
-            <a:spLocks noGrp="1"/>
-          </p:cNvSpPr>
+      <p:pic>
+        <p:nvPicPr>
+          <p:cNvPr id="4" name="Content Placeholder 3">
+            <a:extLst>
+              <a:ext uri="{FF2B5EF4-FFF2-40B4-BE49-F238E27FC236}">
+                <a16:creationId xmlns:a16="http://schemas.microsoft.com/office/drawing/2014/main" id="{EB23AA86-0347-E907-00E5-311F89AD9866}"/>
+              </a:ext>
+            </a:extLst>
+          </p:cNvPr>
+          <p:cNvPicPr>
+            <a:picLocks noGrp="1" noChangeAspect="1"/>
+          </p:cNvPicPr>
           <p:nvPr>
             <p:ph idx="1"/>
           </p:nvPr>
-        </p:nvSpPr>
+        </p:nvPicPr>
+        <p:blipFill>
+          <a:blip r:embed="rId2"/>
+          <a:stretch>
+            <a:fillRect/>
+          </a:stretch>
+        </p:blipFill>
         <p:spPr>
           <a:xfrm>
-            <a:off x="838200" y="1690687"/>
-            <a:ext cx="10727724" cy="4802187"/>
+            <a:off x="838199" y="1690688"/>
+            <a:ext cx="5664573" cy="3453880"/>
           </a:xfrm>
+          <a:prstGeom prst="rect">
+            <a:avLst/>
+          </a:prstGeom>
         </p:spPr>
-        <p:txBody>
-          <a:bodyPr>
-            <a:normAutofit/>
+      </p:pic>
+      <p:pic>
+        <p:nvPicPr>
+          <p:cNvPr id="5" name="Picture 4">
+            <a:extLst>
+              <a:ext uri="{FF2B5EF4-FFF2-40B4-BE49-F238E27FC236}">
+                <a16:creationId xmlns:a16="http://schemas.microsoft.com/office/drawing/2014/main" id="{BA2BFCFD-99BB-9C59-7239-0B6BA5CA3DD6}"/>
+              </a:ext>
+            </a:extLst>
+          </p:cNvPr>
+          <p:cNvPicPr>
+            <a:picLocks noChangeAspect="1"/>
+          </p:cNvPicPr>
+          <p:nvPr/>
+        </p:nvPicPr>
+        <p:blipFill>
+          <a:blip r:embed="rId3"/>
+          <a:stretch>
+            <a:fillRect/>
+          </a:stretch>
+        </p:blipFill>
+        <p:spPr>
+          <a:xfrm>
+            <a:off x="838198" y="5144568"/>
+            <a:ext cx="5664573" cy="1508871"/>
+          </a:xfrm>
+          <a:prstGeom prst="rect">
+            <a:avLst/>
+          </a:prstGeom>
+        </p:spPr>
+      </p:pic>
+      <p:pic>
+        <p:nvPicPr>
+          <p:cNvPr id="7" name="Picture 6">
+            <a:extLst>
+              <a:ext uri="{FF2B5EF4-FFF2-40B4-BE49-F238E27FC236}">
+                <a16:creationId xmlns:a16="http://schemas.microsoft.com/office/drawing/2014/main" id="{1A1343B1-AAF5-6824-B3D2-3333C05B7473}"/>
+              </a:ext>
+            </a:extLst>
+          </p:cNvPr>
+          <p:cNvPicPr>
+            <a:picLocks noChangeAspect="1"/>
+          </p:cNvPicPr>
+          <p:nvPr/>
+        </p:nvPicPr>
+        <p:blipFill>
+          <a:blip r:embed="rId4"/>
+          <a:stretch>
+            <a:fillRect/>
+          </a:stretch>
+        </p:blipFill>
+        <p:spPr>
+          <a:xfrm>
+            <a:off x="6502773" y="1690688"/>
+            <a:ext cx="5308227" cy="4962752"/>
+          </a:xfrm>
+          <a:prstGeom prst="rect">
+            <a:avLst/>
+          </a:prstGeom>
+        </p:spPr>
+      </p:pic>
+      <p:sp>
+        <p:nvSpPr>
+          <p:cNvPr id="9" name="TextBox 8">
+            <a:extLst>
+              <a:ext uri="{FF2B5EF4-FFF2-40B4-BE49-F238E27FC236}">
+                <a16:creationId xmlns:a16="http://schemas.microsoft.com/office/drawing/2014/main" id="{EE2CCEB0-1850-0A8F-DE91-C9F4140C0D6D}"/>
+              </a:ext>
+            </a:extLst>
+          </p:cNvPr>
+          <p:cNvSpPr txBox="1"/>
+          <p:nvPr/>
+        </p:nvSpPr>
+        <p:spPr>
+          <a:xfrm>
+            <a:off x="2290273" y="2556177"/>
+            <a:ext cx="4212499" cy="646331"/>
+          </a:xfrm>
+          <a:prstGeom prst="rect">
+            <a:avLst/>
+          </a:prstGeom>
+          <a:noFill/>
+        </p:spPr>
+        <p:txBody>
+          <a:bodyPr wrap="square">
+            <a:spAutoFit/>
           </a:bodyPr>
           <a:lstStyle/>
           <a:p>
             <a:r>
-              <a:rPr lang="en-US" dirty="0"/>
-              <a:t>Data from 2016 to 2021</a:t>
-            </a:r>
-          </a:p>
-          <a:p>
-            <a:pPr lvl="1"/>
-            <a:r>
-              <a:rPr lang="en-US" b="0" i="0" u="none" strike="noStrike" dirty="0">
-                <a:solidFill>
-                  <a:srgbClr val="000000"/>
-                </a:solidFill>
-                <a:effectLst/>
-              </a:rPr>
-              <a:t>Donors &amp; Recipients in a single row </a:t>
-            </a:r>
-            <a:endParaRPr lang="en-US" dirty="0"/>
-          </a:p>
-          <a:p>
-            <a:r>
-              <a:rPr lang="en-US" dirty="0"/>
-              <a:t>Number of Numeric features</a:t>
-            </a:r>
-          </a:p>
-          <a:p>
-            <a:pPr lvl="1"/>
-            <a:r>
-              <a:rPr lang="en-US" dirty="0"/>
-              <a:t>64 features</a:t>
+              <a:rPr lang="en-US" sz="1200" dirty="0"/>
+              <a:t>Gaussian Mixture Model (GMM) with different numbers of </a:t>
+            </a:r>
+          </a:p>
+          <a:p>
+            <a:r>
+              <a:rPr lang="en-US" sz="1200" dirty="0"/>
+              <a:t>components (clusters) and use information criteria (AIC and BIC) to determine the optimal number of. components.</a:t>
             </a:r>
           </a:p>
         </p:txBody>
@@ -4074,210 +4135,207 @@
           <a:p>
             <a:r>
               <a:rPr lang="en-US" dirty="0"/>
-              <a:t>Additional Data Cleaning Cont…</a:t>
-            </a:r>
-          </a:p>
-        </p:txBody>
-      </p:sp>
-      <p:sp>
-        <p:nvSpPr>
-          <p:cNvPr id="3" name="Content Placeholder 2">
-            <a:extLst>
-              <a:ext uri="{FF2B5EF4-FFF2-40B4-BE49-F238E27FC236}">
-                <a16:creationId xmlns:a16="http://schemas.microsoft.com/office/drawing/2014/main" id="{E729A7DE-E367-BE1F-3E68-83500AB5F665}"/>
-              </a:ext>
-            </a:extLst>
-          </p:cNvPr>
-          <p:cNvSpPr>
-            <a:spLocks noGrp="1"/>
-          </p:cNvSpPr>
-          <p:nvPr>
-            <p:ph idx="1"/>
-          </p:nvPr>
-        </p:nvSpPr>
-        <p:spPr>
-          <a:xfrm>
-            <a:off x="838199" y="1825624"/>
-            <a:ext cx="10665941" cy="4667251"/>
-          </a:xfrm>
-        </p:spPr>
-        <p:txBody>
-          <a:bodyPr>
-            <a:normAutofit fontScale="62500" lnSpcReduction="20000"/>
-          </a:bodyPr>
-          <a:lstStyle/>
-          <a:p>
-            <a:r>
-              <a:rPr lang="en-US" dirty="0"/>
-              <a:t>Additional </a:t>
-            </a:r>
-            <a:r>
-              <a:rPr lang="en-US" b="0" i="0" dirty="0">
-                <a:solidFill>
-                  <a:srgbClr val="001D35"/>
-                </a:solidFill>
-                <a:effectLst/>
-                <a:latin typeface="Google Sans"/>
-              </a:rPr>
-              <a:t>Data wrangling</a:t>
-            </a:r>
-            <a:endParaRPr lang="en-US" dirty="0"/>
-          </a:p>
-          <a:p>
-            <a:pPr lvl="1"/>
-            <a:r>
-              <a:rPr lang="en-US" dirty="0"/>
-              <a:t>Remove Unwanted Features</a:t>
-            </a:r>
-          </a:p>
-          <a:p>
-            <a:pPr lvl="2"/>
-            <a:r>
-              <a:rPr lang="en-US" dirty="0"/>
-              <a:t>PrimaryPaymentSource/WorkIncome/TransplantState/ResidencyState/etc.</a:t>
-            </a:r>
-          </a:p>
-          <a:p>
-            <a:pPr lvl="2"/>
-            <a:r>
-              <a:rPr lang="en-US" dirty="0"/>
-              <a:t>OtherMedsText1/OtherMedsText2/OtherMedsText3/VentricularDeviceType/etc.</a:t>
-            </a:r>
-          </a:p>
-          <a:p>
-            <a:pPr lvl="2"/>
-            <a:r>
-              <a:rPr lang="en-US" dirty="0"/>
-              <a:t>BMI/PreviousTransplantAnyOrgan &amp; PreviousTransplantSameOrgan</a:t>
-            </a:r>
-          </a:p>
-          <a:p>
-            <a:pPr lvl="1"/>
-            <a:r>
-              <a:rPr lang="en-US" b="0" i="0" dirty="0">
-                <a:solidFill>
-                  <a:srgbClr val="001D35"/>
-                </a:solidFill>
-                <a:effectLst/>
-                <a:latin typeface="Google Sans"/>
-              </a:rPr>
-              <a:t>Categorizing features</a:t>
-            </a:r>
-          </a:p>
-          <a:p>
-            <a:pPr lvl="2"/>
+              <a:t>Data </a:t>
+            </a:r>
             <a:r>
               <a:rPr lang="en-US" i="0" dirty="0">
                 <a:effectLst/>
                 <a:latin typeface="system-ui"/>
               </a:rPr>
-              <a:t>PanelReactiveAntibody</a:t>
-            </a:r>
-          </a:p>
-          <a:p>
-            <a:pPr lvl="3"/>
-            <a:r>
-              <a:rPr lang="en-US" b="0" i="0" dirty="0">
+              <a:t>Discretization </a:t>
+            </a:r>
+            <a:r>
+              <a:rPr lang="en-US" dirty="0"/>
+              <a:t>Cont…</a:t>
+            </a:r>
+          </a:p>
+        </p:txBody>
+      </p:sp>
+      <p:sp>
+        <p:nvSpPr>
+          <p:cNvPr id="3" name="Content Placeholder 2">
+            <a:extLst>
+              <a:ext uri="{FF2B5EF4-FFF2-40B4-BE49-F238E27FC236}">
+                <a16:creationId xmlns:a16="http://schemas.microsoft.com/office/drawing/2014/main" id="{E729A7DE-E367-BE1F-3E68-83500AB5F665}"/>
+              </a:ext>
+            </a:extLst>
+          </p:cNvPr>
+          <p:cNvSpPr>
+            <a:spLocks noGrp="1"/>
+          </p:cNvSpPr>
+          <p:nvPr>
+            <p:ph idx="1"/>
+          </p:nvPr>
+        </p:nvSpPr>
+        <p:spPr>
+          <a:xfrm>
+            <a:off x="838199" y="1825625"/>
+            <a:ext cx="5075491" cy="1097037"/>
+          </a:xfrm>
+        </p:spPr>
+        <p:txBody>
+          <a:bodyPr>
+            <a:normAutofit fontScale="62500" lnSpcReduction="20000"/>
+          </a:bodyPr>
+          <a:lstStyle/>
+          <a:p>
+            <a:r>
+              <a:rPr lang="en-US" dirty="0"/>
+              <a:t>Blood PH</a:t>
+            </a:r>
+          </a:p>
+          <a:p>
+            <a:pPr lvl="1"/>
+            <a:r>
+              <a:rPr lang="en-US" sz="1200" dirty="0"/>
+              <a:t>The normal blood pH range is indeed between 7.35 and 7.45. This slightly alkaline range is crucial for the proper functioning of enzymes and other biochemical reactions in the body.</a:t>
+            </a:r>
+          </a:p>
+          <a:p>
+            <a:pPr lvl="1"/>
+            <a:r>
+              <a:rPr lang="en-US" sz="1200" dirty="0"/>
+              <a:t>A blood pH below 7.35 is considered acidic, and it can lead to a condition called acidosis. Acidosis can disrupt cellular functions and impair organ systems, particularly the cardiovascular and respiratory systems.</a:t>
+            </a:r>
+          </a:p>
+          <a:p>
+            <a:pPr lvl="1"/>
+            <a:r>
+              <a:rPr lang="en-US" sz="1200" dirty="0"/>
+              <a:t>A blood pH above 7.45 is considered alkaline, and it can lead to a condition called alkalosis. Alkalosis can cause symptoms such as muscle twitching, hand tremors, and confusion.</a:t>
+            </a:r>
+          </a:p>
+        </p:txBody>
+      </p:sp>
+      <p:pic>
+        <p:nvPicPr>
+          <p:cNvPr id="4" name="Picture 3">
+            <a:extLst>
+              <a:ext uri="{FF2B5EF4-FFF2-40B4-BE49-F238E27FC236}">
+                <a16:creationId xmlns:a16="http://schemas.microsoft.com/office/drawing/2014/main" id="{9AA9C8CF-A77F-4EA0-27D1-95D14E9D84D0}"/>
+              </a:ext>
+            </a:extLst>
+          </p:cNvPr>
+          <p:cNvPicPr>
+            <a:picLocks noChangeAspect="1"/>
+          </p:cNvPicPr>
+          <p:nvPr/>
+        </p:nvPicPr>
+        <p:blipFill>
+          <a:blip r:embed="rId2"/>
+          <a:stretch>
+            <a:fillRect/>
+          </a:stretch>
+        </p:blipFill>
+        <p:spPr>
+          <a:xfrm>
+            <a:off x="777668" y="3345694"/>
+            <a:ext cx="5075491" cy="2705100"/>
+          </a:xfrm>
+          <a:prstGeom prst="rect">
+            <a:avLst/>
+          </a:prstGeom>
+        </p:spPr>
+      </p:pic>
+      <p:sp>
+        <p:nvSpPr>
+          <p:cNvPr id="6" name="TextBox 5">
+            <a:extLst>
+              <a:ext uri="{FF2B5EF4-FFF2-40B4-BE49-F238E27FC236}">
+                <a16:creationId xmlns:a16="http://schemas.microsoft.com/office/drawing/2014/main" id="{727013F3-8C9B-E132-6198-386F5CE5BC8F}"/>
+              </a:ext>
+            </a:extLst>
+          </p:cNvPr>
+          <p:cNvSpPr txBox="1"/>
+          <p:nvPr/>
+        </p:nvSpPr>
+        <p:spPr>
+          <a:xfrm>
+            <a:off x="6853727" y="1825625"/>
+            <a:ext cx="4742916" cy="369332"/>
+          </a:xfrm>
+          <a:prstGeom prst="rect">
+            <a:avLst/>
+          </a:prstGeom>
+          <a:noFill/>
+        </p:spPr>
+        <p:txBody>
+          <a:bodyPr wrap="square">
+            <a:spAutoFit/>
+          </a:bodyPr>
+          <a:lstStyle/>
+          <a:p>
+            <a:pPr algn="l"/>
+            <a:r>
+              <a:rPr lang="en-US" b="1" i="0" dirty="0">
                 <a:effectLst/>
                 <a:latin typeface="system-ui"/>
               </a:rPr>
-              <a:t>CPRA values typically range from 0% to 100%</a:t>
-            </a:r>
-            <a:endParaRPr lang="en-US" dirty="0"/>
-          </a:p>
-          <a:p>
-            <a:pPr lvl="1"/>
-            <a:r>
-              <a:rPr lang="en-US" dirty="0"/>
-              <a:t>Remove After &amp; Labels</a:t>
-            </a:r>
-          </a:p>
-          <a:p>
-            <a:pPr lvl="2"/>
-            <a:r>
-              <a:rPr lang="en-US" b="0" i="0" dirty="0">
-                <a:effectLst/>
-                <a:latin typeface="system-ui"/>
-              </a:rPr>
-              <a:t>FollowUpFunctionalStatus/AcuteRejectionEpisode/StrokePostTransplant/etc.</a:t>
-            </a:r>
-          </a:p>
-          <a:p>
-            <a:pPr lvl="1"/>
-            <a:r>
-              <a:rPr lang="en-US" dirty="0"/>
-              <a:t>Consolidate Categories</a:t>
-            </a:r>
-          </a:p>
-          <a:p>
-            <a:pPr lvl="2"/>
-            <a:r>
-              <a:rPr lang="en-US" dirty="0"/>
-              <a:t>Diagnosis Codes/Prior Cardiac Surgery Type</a:t>
-            </a:r>
-          </a:p>
-          <a:p>
-            <a:pPr lvl="3"/>
-            <a:r>
-              <a:rPr lang="en-US" dirty="0"/>
-              <a:t>Consolidate different types Codes</a:t>
-            </a:r>
-          </a:p>
-          <a:p>
-            <a:pPr lvl="4"/>
-            <a:r>
-              <a:rPr lang="en-US" dirty="0"/>
-              <a:t>Reduce the number of categories</a:t>
-            </a:r>
-          </a:p>
-          <a:p>
-            <a:pPr lvl="1"/>
-            <a:r>
-              <a:rPr lang="en-US" dirty="0"/>
-              <a:t>Remove Unknown Features &amp; NaNs</a:t>
-            </a:r>
-          </a:p>
-          <a:p>
-            <a:pPr lvl="2"/>
-            <a:r>
-              <a:rPr lang="en-US" dirty="0"/>
-              <a:t>DAYS_STAT1A/DAYS_STATA4/DAYS_STATA3/etc.</a:t>
-            </a:r>
-          </a:p>
-          <a:p>
-            <a:pPr marL="457200" lvl="1" indent="0">
-              <a:buNone/>
-            </a:pPr>
-            <a:endParaRPr lang="en-US" dirty="0"/>
-          </a:p>
-          <a:p>
-            <a:r>
-              <a:rPr lang="en-US" dirty="0"/>
-              <a:t>Total of 14,856 records and 113 features</a:t>
-            </a:r>
-          </a:p>
-          <a:p>
-            <a:pPr marL="0" indent="0">
-              <a:buNone/>
-            </a:pPr>
-            <a:endParaRPr lang="en-US" dirty="0"/>
-          </a:p>
-          <a:p>
-            <a:pPr lvl="1"/>
-            <a:r>
-              <a:rPr lang="en-US" b="1" dirty="0"/>
-              <a:t>Note</a:t>
-            </a:r>
-            <a:r>
-              <a:rPr lang="en-US" dirty="0"/>
-              <a:t>: Hypothesis testing using Chi-square statistic and calculating Cramer's V to build consensus for the categorical variables while consolidating categorical variables</a:t>
-            </a:r>
-          </a:p>
-          <a:p>
-            <a:endParaRPr lang="en-US" dirty="0"/>
-          </a:p>
-        </p:txBody>
-      </p:sp>
+              <a:t>DistanceFromDonorHospitaltoTXCenter</a:t>
+            </a:r>
+          </a:p>
+        </p:txBody>
+      </p:sp>
+      <p:pic>
+        <p:nvPicPr>
+          <p:cNvPr id="7" name="Picture 6">
+            <a:extLst>
+              <a:ext uri="{FF2B5EF4-FFF2-40B4-BE49-F238E27FC236}">
+                <a16:creationId xmlns:a16="http://schemas.microsoft.com/office/drawing/2014/main" id="{2C0A6C16-2934-844B-3CC2-6796154D2735}"/>
+              </a:ext>
+            </a:extLst>
+          </p:cNvPr>
+          <p:cNvPicPr>
+            <a:picLocks noChangeAspect="1"/>
+          </p:cNvPicPr>
+          <p:nvPr/>
+        </p:nvPicPr>
+        <p:blipFill>
+          <a:blip r:embed="rId3"/>
+          <a:stretch>
+            <a:fillRect/>
+          </a:stretch>
+        </p:blipFill>
+        <p:spPr>
+          <a:xfrm>
+            <a:off x="6922093" y="2194957"/>
+            <a:ext cx="5075490" cy="2301474"/>
+          </a:xfrm>
+          <a:prstGeom prst="rect">
+            <a:avLst/>
+          </a:prstGeom>
+        </p:spPr>
+      </p:pic>
+      <p:pic>
+        <p:nvPicPr>
+          <p:cNvPr id="8" name="Picture 7">
+            <a:extLst>
+              <a:ext uri="{FF2B5EF4-FFF2-40B4-BE49-F238E27FC236}">
+                <a16:creationId xmlns:a16="http://schemas.microsoft.com/office/drawing/2014/main" id="{A8FA2FE1-A606-638B-2E04-31F64023DD96}"/>
+              </a:ext>
+            </a:extLst>
+          </p:cNvPr>
+          <p:cNvPicPr>
+            <a:picLocks noChangeAspect="1"/>
+          </p:cNvPicPr>
+          <p:nvPr/>
+        </p:nvPicPr>
+        <p:blipFill>
+          <a:blip r:embed="rId4"/>
+          <a:stretch>
+            <a:fillRect/>
+          </a:stretch>
+        </p:blipFill>
+        <p:spPr>
+          <a:xfrm>
+            <a:off x="6922092" y="4496431"/>
+            <a:ext cx="5075491" cy="2169289"/>
+          </a:xfrm>
+          <a:prstGeom prst="rect">
+            <a:avLst/>
+          </a:prstGeom>
+        </p:spPr>
+      </p:pic>
     </p:spTree>
     <p:extLst>
       <p:ext uri="{BB962C8B-B14F-4D97-AF65-F5344CB8AC3E}">
@@ -4292,6 +4350,303 @@
 </file>
 
 <file path=ppt/slides/slide5.xml><?xml version="1.0" encoding="utf-8"?>
+<p:sld xmlns:a="http://schemas.openxmlformats.org/drawingml/2006/main" xmlns:r="http://schemas.openxmlformats.org/officeDocument/2006/relationships" xmlns:p="http://schemas.openxmlformats.org/presentationml/2006/main">
+  <p:cSld>
+    <p:bg>
+      <p:bgPr>
+        <a:gradFill>
+          <a:gsLst>
+            <a:gs pos="0">
+              <a:schemeClr val="accent1">
+                <a:lumMod val="5000"/>
+                <a:lumOff val="95000"/>
+              </a:schemeClr>
+            </a:gs>
+            <a:gs pos="74000">
+              <a:schemeClr val="accent1">
+                <a:lumMod val="45000"/>
+                <a:lumOff val="55000"/>
+              </a:schemeClr>
+            </a:gs>
+            <a:gs pos="83000">
+              <a:schemeClr val="accent1">
+                <a:lumMod val="45000"/>
+                <a:lumOff val="55000"/>
+              </a:schemeClr>
+            </a:gs>
+            <a:gs pos="100000">
+              <a:schemeClr val="accent1">
+                <a:lumMod val="30000"/>
+                <a:lumOff val="70000"/>
+              </a:schemeClr>
+            </a:gs>
+          </a:gsLst>
+          <a:lin ang="5400000" scaled="1"/>
+        </a:gradFill>
+        <a:effectLst/>
+      </p:bgPr>
+    </p:bg>
+    <p:spTree>
+      <p:nvGrpSpPr>
+        <p:cNvPr id="1" name="">
+          <a:extLst>
+            <a:ext uri="{FF2B5EF4-FFF2-40B4-BE49-F238E27FC236}">
+              <a16:creationId xmlns:a16="http://schemas.microsoft.com/office/drawing/2014/main" id="{0CEC5946-99BF-03C4-402A-A13FA1FCFAD8}"/>
+            </a:ext>
+          </a:extLst>
+        </p:cNvPr>
+        <p:cNvGrpSpPr/>
+        <p:nvPr/>
+      </p:nvGrpSpPr>
+      <p:grpSpPr>
+        <a:xfrm>
+          <a:off x="0" y="0"/>
+          <a:ext cx="0" cy="0"/>
+          <a:chOff x="0" y="0"/>
+          <a:chExt cx="0" cy="0"/>
+        </a:xfrm>
+      </p:grpSpPr>
+      <p:sp>
+        <p:nvSpPr>
+          <p:cNvPr id="2" name="Title 1">
+            <a:extLst>
+              <a:ext uri="{FF2B5EF4-FFF2-40B4-BE49-F238E27FC236}">
+                <a16:creationId xmlns:a16="http://schemas.microsoft.com/office/drawing/2014/main" id="{F36FFA81-E25E-A2DA-4C46-CB4760F125CB}"/>
+              </a:ext>
+            </a:extLst>
+          </p:cNvPr>
+          <p:cNvSpPr>
+            <a:spLocks noGrp="1"/>
+          </p:cNvSpPr>
+          <p:nvPr>
+            <p:ph type="title"/>
+          </p:nvPr>
+        </p:nvSpPr>
+        <p:spPr/>
+        <p:txBody>
+          <a:bodyPr/>
+          <a:lstStyle/>
+          <a:p>
+            <a:r>
+              <a:rPr lang="en-US" dirty="0"/>
+              <a:t>Additional Data Cleaning Cont…</a:t>
+            </a:r>
+          </a:p>
+        </p:txBody>
+      </p:sp>
+      <p:sp>
+        <p:nvSpPr>
+          <p:cNvPr id="3" name="Content Placeholder 2">
+            <a:extLst>
+              <a:ext uri="{FF2B5EF4-FFF2-40B4-BE49-F238E27FC236}">
+                <a16:creationId xmlns:a16="http://schemas.microsoft.com/office/drawing/2014/main" id="{3777F0FA-6EAB-D82F-697A-5374C944DBEA}"/>
+              </a:ext>
+            </a:extLst>
+          </p:cNvPr>
+          <p:cNvSpPr>
+            <a:spLocks noGrp="1"/>
+          </p:cNvSpPr>
+          <p:nvPr>
+            <p:ph idx="1"/>
+          </p:nvPr>
+        </p:nvSpPr>
+        <p:spPr>
+          <a:xfrm>
+            <a:off x="838199" y="1825624"/>
+            <a:ext cx="10665941" cy="4667251"/>
+          </a:xfrm>
+        </p:spPr>
+        <p:txBody>
+          <a:bodyPr>
+            <a:normAutofit fontScale="62500" lnSpcReduction="20000"/>
+          </a:bodyPr>
+          <a:lstStyle/>
+          <a:p>
+            <a:r>
+              <a:rPr lang="en-US" dirty="0"/>
+              <a:t>Additional </a:t>
+            </a:r>
+            <a:r>
+              <a:rPr lang="en-US" b="0" i="0" dirty="0">
+                <a:solidFill>
+                  <a:srgbClr val="001D35"/>
+                </a:solidFill>
+                <a:effectLst/>
+                <a:latin typeface="Google Sans"/>
+              </a:rPr>
+              <a:t>Data wrangling</a:t>
+            </a:r>
+            <a:endParaRPr lang="en-US" dirty="0"/>
+          </a:p>
+          <a:p>
+            <a:pPr lvl="1"/>
+            <a:r>
+              <a:rPr lang="en-US" dirty="0"/>
+              <a:t>Remove Unwanted Features</a:t>
+            </a:r>
+          </a:p>
+          <a:p>
+            <a:pPr lvl="2"/>
+            <a:r>
+              <a:rPr lang="en-US" dirty="0"/>
+              <a:t>PrimaryPaymentSource/WorkIncome/TransplantState/ResidencyState/etc.</a:t>
+            </a:r>
+          </a:p>
+          <a:p>
+            <a:pPr lvl="2"/>
+            <a:r>
+              <a:rPr lang="en-US" dirty="0"/>
+              <a:t>OtherMedsText1/OtherMedsText2/OtherMedsText3/VentricularDeviceType/etc.</a:t>
+            </a:r>
+          </a:p>
+          <a:p>
+            <a:pPr lvl="2"/>
+            <a:r>
+              <a:rPr lang="en-US" dirty="0"/>
+              <a:t>BMI/PreviousTransplantAnyOrgan &amp; PreviousTransplantSameOrgan</a:t>
+            </a:r>
+          </a:p>
+          <a:p>
+            <a:pPr lvl="1"/>
+            <a:r>
+              <a:rPr lang="en-US" b="0" i="0" dirty="0">
+                <a:solidFill>
+                  <a:srgbClr val="001D35"/>
+                </a:solidFill>
+                <a:effectLst/>
+                <a:latin typeface="Google Sans"/>
+              </a:rPr>
+              <a:t>Categorizing features</a:t>
+            </a:r>
+          </a:p>
+          <a:p>
+            <a:pPr lvl="2"/>
+            <a:r>
+              <a:rPr lang="en-US" i="0" dirty="0">
+                <a:effectLst/>
+                <a:latin typeface="system-ui"/>
+              </a:rPr>
+              <a:t>PanelReactiveAntibody</a:t>
+            </a:r>
+          </a:p>
+          <a:p>
+            <a:pPr lvl="3"/>
+            <a:r>
+              <a:rPr lang="en-US" b="0" i="0" dirty="0">
+                <a:effectLst/>
+                <a:latin typeface="system-ui"/>
+              </a:rPr>
+              <a:t>CPRA values typically range from 0% to 100%</a:t>
+            </a:r>
+            <a:endParaRPr lang="en-US" dirty="0"/>
+          </a:p>
+          <a:p>
+            <a:pPr lvl="1"/>
+            <a:r>
+              <a:rPr lang="en-US" dirty="0"/>
+              <a:t>Remove After &amp; Labels</a:t>
+            </a:r>
+          </a:p>
+          <a:p>
+            <a:pPr lvl="2"/>
+            <a:r>
+              <a:rPr lang="en-US" b="0" i="0" dirty="0">
+                <a:effectLst/>
+                <a:latin typeface="system-ui"/>
+              </a:rPr>
+              <a:t>FollowUpFunctionalStatus/AcuteRejectionEpisode/StrokePostTransplant/etc.</a:t>
+            </a:r>
+          </a:p>
+          <a:p>
+            <a:pPr lvl="1"/>
+            <a:r>
+              <a:rPr lang="en-US" dirty="0"/>
+              <a:t>Consolidate Categories</a:t>
+            </a:r>
+          </a:p>
+          <a:p>
+            <a:pPr lvl="2"/>
+            <a:r>
+              <a:rPr lang="en-US" dirty="0"/>
+              <a:t>Diagnosis Codes/Prior Cardiac Surgery Type</a:t>
+            </a:r>
+          </a:p>
+          <a:p>
+            <a:pPr lvl="3"/>
+            <a:r>
+              <a:rPr lang="en-US" dirty="0"/>
+              <a:t>Consolidate different types Codes</a:t>
+            </a:r>
+          </a:p>
+          <a:p>
+            <a:pPr lvl="4"/>
+            <a:r>
+              <a:rPr lang="en-US" dirty="0"/>
+              <a:t>Reduce the number of categories</a:t>
+            </a:r>
+          </a:p>
+          <a:p>
+            <a:pPr lvl="1"/>
+            <a:r>
+              <a:rPr lang="en-US" dirty="0"/>
+              <a:t>Remove Unknown Features &amp; NaNs</a:t>
+            </a:r>
+          </a:p>
+          <a:p>
+            <a:pPr lvl="2"/>
+            <a:r>
+              <a:rPr lang="en-US" dirty="0"/>
+              <a:t>DAYS_STAT1A/DAYS_STATA4/DAYS_STATA3/etc.</a:t>
+            </a:r>
+          </a:p>
+          <a:p>
+            <a:pPr marL="457200" lvl="1" indent="0">
+              <a:buNone/>
+            </a:pPr>
+            <a:endParaRPr lang="en-US" dirty="0"/>
+          </a:p>
+          <a:p>
+            <a:r>
+              <a:rPr lang="en-US" dirty="0"/>
+              <a:t>Total of 14,856 records and 113 features</a:t>
+            </a:r>
+          </a:p>
+          <a:p>
+            <a:pPr marL="0" indent="0">
+              <a:buNone/>
+            </a:pPr>
+            <a:endParaRPr lang="en-US" dirty="0"/>
+          </a:p>
+          <a:p>
+            <a:pPr lvl="1"/>
+            <a:r>
+              <a:rPr lang="en-US" b="1" dirty="0"/>
+              <a:t>Note</a:t>
+            </a:r>
+            <a:r>
+              <a:rPr lang="en-US" dirty="0"/>
+              <a:t>: Hypothesis testing using Chi-square statistic and calculating Cramer's V to build consensus for the categorical variables while consolidating categorical variables</a:t>
+            </a:r>
+          </a:p>
+          <a:p>
+            <a:endParaRPr lang="en-US" dirty="0"/>
+          </a:p>
+        </p:txBody>
+      </p:sp>
+    </p:spTree>
+    <p:extLst>
+      <p:ext uri="{BB962C8B-B14F-4D97-AF65-F5344CB8AC3E}">
+        <p14:creationId xmlns:p14="http://schemas.microsoft.com/office/powerpoint/2010/main" val="651046311"/>
+      </p:ext>
+    </p:extLst>
+  </p:cSld>
+  <p:clrMapOvr>
+    <a:masterClrMapping/>
+  </p:clrMapOvr>
+</p:sld>
+</file>
+
+<file path=ppt/slides/slide6.xml><?xml version="1.0" encoding="utf-8"?>
 <p:sld xmlns:a="http://schemas.openxmlformats.org/drawingml/2006/main" xmlns:r="http://schemas.openxmlformats.org/officeDocument/2006/relationships" xmlns:p="http://schemas.openxmlformats.org/presentationml/2006/main">
   <p:cSld>
     <p:bg>

</xml_diff>